<commit_message>
590: add the session reading list and fix lecture citations
syllabus.md gains a session-by-session reading list, with required,
optional and in-class readings and DOIs where they exist. The schedule
table's reading column now names them. The Word syllabus is rebuilt
from it. Sessions 5-7 had no readings; those entries are suggestions
for instructor review.

In the lecture Markdown and PowerPoints:
- Weber now cites Gerth & Mills (1946).
- Spivak now cites the 1988 Nelson & Grossberg chapter; Lecture 4's
  citation was missing its title.
- "Zhang et al. (2025)" is corrected to Liu et al. (2025).
- The Liu et al. link carried a personal ScienceDirect access token;
  it now points to the DOI.

_drafts/reading-list-draft-2026-10-17.md keeps the annotated draft.

Co-Authored-By: Claude Opus 5.5 <noreply@anthropic.com>
</commit_message>
<xml_diff>
--- a/courses/590-fall-2026/590-lecture-2.pptx
+++ b/courses/590-fall-2026/590-lecture-2.pptx
@@ -6093,7 +6093,7 @@
             </a:pPr>
             <a:r>
               <a:rPr/>
-              <a:t>Liu, J., Zhang, Y., Li, W., Wang, Q., Niu, P., &amp; Zhang, X. (2025). Adaptive vs. Planned Metacognitive Scaffolding for Computational Thinking: Evidence from Generative AI-Supported Programming in Elementary Education. Computers &amp; Education, 105473. https://www.sciencedirect.com/science/article/pii/S0360131525002416?casa_token=cBNpQ0r7f4oAAAAA:THnluE0eVY1uTJ3bnp1V6j-fsLEXobOB6QqoszFx_hsNacpAVPMmIe61gO70IXtFPiT2vIRcGPk</a:t>
+              <a:t>Liu, J., Zhang, Y., Li, W., Wang, Q., Niu, P., &amp; Zhang, X. (2025). Adaptive vs. Planned Metacognitive Scaffolding for Computational Thinking: Evidence from Generative AI-Supported Programming in Elementary Education. Computers &amp; Education, 105473. https://doi.org/10.1016/j.compedu.2025.105473</a:t>
             </a:r>
           </a:p>
           <a:p>
@@ -6102,7 +6102,7 @@
             </a:pPr>
             <a:r>
               <a:rPr/>
-              <a:t>Spivak, G. C. (2023). Can the subaltern speak?. In Imperialism (pp. 171-219). Routledge. http://users.uoa.gr/~cdokou/TheoryCriticismTexts/Spivak-Subaltern.pdf</a:t>
+              <a:t>Spivak, G. C. (1988). Can the subaltern speak? In C. Nelson &amp; L. Grossberg (Eds.), Marxism and the interpretation of culture (pp. 271–313). University of Illinois Press. http://users.uoa.gr/~cdokou/TheoryCriticismTexts/Spivak-Subaltern.pdf</a:t>
             </a:r>
           </a:p>
           <a:p>
@@ -6372,7 +6372,7 @@
             </a:pPr>
             <a:r>
               <a:rPr/>
-              <a:t>Liu, J., Zhang, Y., Li, W., Wang, Q., Niu, P., &amp; Zhang, X. (2025). Adaptive vs. Planned Metacognitive Scaffolding for Computational Thinking: Evidence from Generative AI-Supported Programming in Elementary Education. Computers &amp; Education, 105473. https://www.sciencedirect.com/science/article/pii/S0360131525002416?casa_token=cBNpQ0r7f4oAAAAA:THnluE0eVY1uTJ3bnp1V6j-fsLEXobOB6QqoszFx_hsNacpAVPMmIe61gO70IXtFPiT2vIRcGPk</a:t>
+              <a:t>Liu, J., Zhang, Y., Li, W., Wang, Q., Niu, P., &amp; Zhang, X. (2025). Adaptive vs. Planned Metacognitive Scaffolding for Computational Thinking: Evidence from Generative AI-Supported Programming in Elementary Education. Computers &amp; Education, 105473. https://doi.org/10.1016/j.compedu.2025.105473</a:t>
             </a:r>
           </a:p>
         </p:txBody>
@@ -6434,7 +6434,7 @@
             </a:pPr>
             <a:r>
               <a:rPr/>
-              <a:t>Spivak, G. C. (2023). Can the subaltern speak?. In Imperialism (pp. 171-219). Routledge. http://users.uoa.gr/~cdokou/TheoryCriticismTexts/Spivak-Subaltern.pdf</a:t>
+              <a:t>Spivak, G. C. (1988). Can the subaltern speak? In C. Nelson &amp; L. Grossberg (Eds.), Marxism and the interpretation of culture (pp. 271–313). University of Illinois Press. http://users.uoa.gr/~cdokou/TheoryCriticismTexts/Spivak-Subaltern.pdf</a:t>
             </a:r>
           </a:p>
         </p:txBody>

</xml_diff>